<commit_message>
add timeline and task distribution and readme file
</commit_message>
<xml_diff>
--- a/project.pptx
+++ b/project.pptx
@@ -6229,19 +6229,11 @@
             </a:r>
             <a:r>
               <a:rPr lang="en-US" sz="3800" dirty="0"/>
-              <a:t> </a:t>
+              <a:t> abo </a:t>
             </a:r>
             <a:r>
               <a:rPr lang="en-US" sz="3800" dirty="0" err="1"/>
-              <a:t>abu</a:t>
-            </a:r>
-            <a:r>
-              <a:rPr lang="en-US" sz="3800" dirty="0"/>
-              <a:t> </a:t>
-            </a:r>
-            <a:r>
-              <a:rPr lang="en-US" sz="3800" dirty="0" err="1"/>
-              <a:t>almagd</a:t>
+              <a:t>elmgd</a:t>
             </a:r>
             <a:br>
               <a:rPr lang="en-US" sz="3800" dirty="0"/>
@@ -7110,11 +7102,11 @@
             </a:r>
             <a:r>
               <a:rPr lang="en-US" b="1" dirty="0"/>
-              <a:t> Abu </a:t>
+              <a:t> Abo </a:t>
             </a:r>
             <a:r>
               <a:rPr lang="en-US" b="1" dirty="0" err="1"/>
-              <a:t>Almagd</a:t>
+              <a:t>elmgd</a:t>
             </a:r>
             <a:r>
               <a:rPr lang="en-US" b="1" dirty="0"/>
@@ -8605,11 +8597,11 @@
             </a:r>
             <a:r>
               <a:rPr lang="en-US" b="1" dirty="0"/>
-              <a:t> Abu </a:t>
+              <a:t> Abo </a:t>
             </a:r>
             <a:r>
               <a:rPr lang="en-US" b="1" dirty="0" err="1"/>
-              <a:t>Almagd</a:t>
+              <a:t>elmgd</a:t>
             </a:r>
             <a:r>
               <a:rPr lang="en-US" b="1" dirty="0"/>

</xml_diff>